<commit_message>
Comité CGN: protocolo y diapositivas alineados con la carta editada; páginas de la carta actualizadas
Co-Authored-By: Claude Opus 5.5 <noreply@anthropic.com>
Claude-Session: https://claude.ai/code/session_01A2a3kkCw22mKtZ4h9yLDKX
</commit_message>
<xml_diff>
--- a/comite_etica_CGN/Exposicion_respuesta_Comite.pptx
+++ b/comite_etica_CGN/Exposicion_respuesta_Comite.pptx
@@ -1548,7 +1548,7 @@
           <a:lstStyle/>
           <a:p>
             <a:r>
-              <a:t>Acogida. El nuevo numeral 3.9.1 desarrolla los ocho elementos: roles de responsable y encargado según la Ley 1581, accesos controlados por la Clínica, codificación sin rastro religioso, almacenamiento cifrado, custodia de claves con destrucción antes del análisis, un procedimiento de incidentes con aviso en 24 horas, reglas contra la identificación indirecta y capacitación previa.</a:t>
+              <a:t>Acogida. El nuevo numeral 3.9.1 desarrolla los ocho elementos: roles de responsable y encargado según la Ley 1581, accesos controlados por la Clínica, codificación sin rastro religioso, almacenamiento cifrado, custodia separada de las claves, un procedimiento de incidentes con aviso en 24 horas, reglas contra la identificación indirecta y minimización de los datos.</a:t>
             </a:r>
           </a:p>
         </p:txBody>
@@ -16606,7 +16606,7 @@
                   <a:srgbClr val="333333"/>
                 </a:solidFill>
               </a:rPr>
-              <a:t>REDCap institucional o archivo cifrado; respaldos cifrados; cinco años y acta.</a:t>
+              <a:t>REDCap institucional o archivo cifrado; respaldos cifrados; conservación por cinco años.</a:t>
             </a:r>
           </a:p>
         </p:txBody>
@@ -16784,7 +16784,7 @@
                   <a:srgbClr val="333333"/>
                 </a:solidFill>
               </a:rPr>
-              <a:t>Archivo cifrado aparte; dos personas; destrucción con acta antes del análisis.</a:t>
+              <a:t>Archivo cifrado aparte, accesible solo a los investigadores; nunca se transmite con la base.</a:t>
             </a:r>
           </a:p>
         </p:txBody>
@@ -17280,7 +17280,7 @@
                   <a:srgbClr val="80006B"/>
                 </a:solidFill>
               </a:rPr>
-              <a:t>Capacitación</a:t>
+              <a:t>Minimización</a:t>
             </a:r>
           </a:p>
         </p:txBody>
@@ -17318,7 +17318,7 @@
                   <a:srgbClr val="333333"/>
                 </a:solidFill>
               </a:rPr>
-              <a:t>Formación vigente en ética de la investigación y buenas prácticas antes del acceso.</a:t>
+              <a:t>Solo los pacientes del listado de elegibilidad y las variables del diccionario.</a:t>
             </a:r>
           </a:p>
         </p:txBody>
@@ -18578,7 +18578,7 @@
                   <a:srgbClr val="6B6B6B"/>
                 </a:solidFill>
               </a:rPr>
-              <a:t>numeral 3.9.2, p. 44 · numeral 3.9.1, p. 43 · numeral 3.10, p. 45</a:t>
+              <a:t>numeral 3.9.2, p. 43 · numeral 3.9.1, p. 43 · numeral 3.10, p. 44</a:t>
             </a:r>
           </a:p>
         </p:txBody>
@@ -21088,7 +21088,7 @@
                             <a:srgbClr val="333333"/>
                           </a:solidFill>
                         </a:rPr>
-                        <a:t>43–45</a:t>
+                        <a:t>43–44</a:t>
                       </a:r>
                     </a:p>
                   </a:txBody>
@@ -21767,100 +21767,6 @@
                   <a:srgbClr val="333333"/>
                 </a:solidFill>
               </a:rPr>
-              <a:t>Remitir los informes de avance que se soliciten y el informe final antes de la difusión.</a:t>
-            </a:r>
-          </a:p>
-        </p:txBody>
-      </p:sp>
-      <p:sp>
-        <p:nvSpPr>
-          <p:cNvPr id="12374" name="Oval 12373"/>
-          <p:cNvSpPr/>
-          <p:nvPr/>
-        </p:nvSpPr>
-        <p:spPr>
-          <a:xfrm>
-            <a:off x="914400" y="5971032"/>
-            <a:ext cx="685800" cy="685800"/>
-          </a:xfrm>
-          <a:prstGeom prst="ellipse">
-            <a:avLst/>
-          </a:prstGeom>
-          <a:solidFill>
-            <a:srgbClr val="80006B"/>
-          </a:solidFill>
-          <a:ln>
-            <a:noFill/>
-          </a:ln>
-          <a:effectLst/>
-        </p:spPr>
-        <p:style>
-          <a:lnRef idx="1">
-            <a:schemeClr val="accent1"/>
-          </a:lnRef>
-          <a:fillRef idx="3">
-            <a:schemeClr val="accent1"/>
-          </a:fillRef>
-          <a:effectRef idx="2">
-            <a:schemeClr val="accent1"/>
-          </a:effectRef>
-          <a:fontRef idx="minor">
-            <a:schemeClr val="lt1"/>
-          </a:fontRef>
-        </p:style>
-        <p:txBody>
-          <a:bodyPr rtlCol="0" anchor="ctr" wrap="square" lIns="0" rIns="0" tIns="0" bIns="0"/>
-          <a:lstStyle/>
-          <a:p>
-            <a:pPr algn="ctr">
-              <a:spcAft>
-                <a:spcPts val="600"/>
-              </a:spcAft>
-            </a:pPr>
-            <a:r>
-              <a:rPr sz="2400" b="1" i="0">
-                <a:solidFill>
-                  <a:srgbClr val="FFFFFF"/>
-                </a:solidFill>
-              </a:rPr>
-              <a:t>5</a:t>
-            </a:r>
-          </a:p>
-        </p:txBody>
-      </p:sp>
-      <p:sp>
-        <p:nvSpPr>
-          <p:cNvPr id="12375" name="TextBox 12374"/>
-          <p:cNvSpPr txBox="1"/>
-          <p:nvPr/>
-        </p:nvSpPr>
-        <p:spPr>
-          <a:xfrm>
-            <a:off x="1828800" y="5971032"/>
-            <a:ext cx="8138160" cy="731520"/>
-          </a:xfrm>
-          <a:prstGeom prst="rect">
-            <a:avLst/>
-          </a:prstGeom>
-          <a:noFill/>
-        </p:spPr>
-        <p:txBody>
-          <a:bodyPr wrap="square" anchor="ctr" lIns="73152" rIns="73152" tIns="73152" bIns="73152">
-            <a:spAutoFit/>
-          </a:bodyPr>
-          <a:lstStyle/>
-          <a:p>
-            <a:pPr algn="l">
-              <a:spcAft>
-                <a:spcPts val="600"/>
-              </a:spcAft>
-            </a:pPr>
-            <a:r>
-              <a:rPr sz="2300" b="0" i="0">
-                <a:solidFill>
-                  <a:srgbClr val="333333"/>
-                </a:solidFill>
-              </a:rPr>
               <a:t>Atender aclaraciones adicionales y sustentar el protocolo cuando el Comité lo requiera.</a:t>
             </a:r>
           </a:p>
@@ -21868,7 +21774,7 @@
       </p:sp>
       <p:sp>
         <p:nvSpPr>
-          <p:cNvPr id="12376" name="Rounded Rectangle 12375"/>
+          <p:cNvPr id="12374" name="Rounded Rectangle 12373"/>
           <p:cNvSpPr/>
           <p:nvPr/>
         </p:nvSpPr>
@@ -21912,7 +21818,7 @@
       </p:sp>
       <p:sp>
         <p:nvSpPr>
-          <p:cNvPr id="12377" name="TextBox 12376"/>
+          <p:cNvPr id="12375" name="TextBox 12374"/>
           <p:cNvSpPr txBox="1"/>
           <p:nvPr/>
         </p:nvSpPr>
@@ -21965,7 +21871,7 @@
       </p:sp>
       <p:sp>
         <p:nvSpPr>
-          <p:cNvPr id="12378" name="TextBox 12377"/>
+          <p:cNvPr id="12376" name="TextBox 12375"/>
           <p:cNvSpPr txBox="1"/>
           <p:nvPr/>
         </p:nvSpPr>
@@ -21996,7 +21902,7 @@
                   <a:srgbClr val="6B6B6B"/>
                 </a:solidFill>
               </a:rPr>
-              <a:t>Anexos radicados: protocolo v2.0 en Word (ajustes resaltados en amarillo) y en PDF (paginación de referencia) y carta de respuesta punto por punto.</a:t>
+              <a:t>Documentos radicados: protocolo v2.0 con los ajustes resaltados en amarillo y carta de respuesta punto por punto.</a:t>
             </a:r>
           </a:p>
         </p:txBody>
@@ -27184,7 +27090,7 @@
                   <a:srgbClr val="80006B"/>
                 </a:solidFill>
               </a:rPr>
-              <a:t>Base analítica (p. 43)</a:t>
+              <a:t>Base analítica (p. 42)</a:t>
             </a:r>
           </a:p>
         </p:txBody>
@@ -27268,7 +27174,7 @@
                   <a:srgbClr val="6B6B6B"/>
                 </a:solidFill>
               </a:rPr>
-              <a:t>numeral 3.2.2, p. 28 · numeral 3.3.1, pp. 29–30 · numeral 3.9.1, p. 43</a:t>
+              <a:t>numeral 3.2.2, p. 28 · numeral 3.3.1, pp. 29–30 · numeral 3.9.1, p. 42</a:t>
             </a:r>
           </a:p>
         </p:txBody>
@@ -28352,7 +28258,7 @@
                   <a:srgbClr val="6B6B6B"/>
                 </a:solidFill>
               </a:rPr>
-              <a:t>p. 6 · numeral 2.1.5, p. 18 · numeral 3.7.1, p. 35 · numeral 3.9.2, p. 44 · referencias 51–53</a:t>
+              <a:t>p. 6 · numeral 2.1.5, p. 18 · numeral 3.7.1, p. 35 · numeral 3.9.2, p. 43 · referencias 51–53</a:t>
             </a:r>
           </a:p>
         </p:txBody>

</xml_diff>

<commit_message>
Comité CGN: carta final en PDF (23-10-2026) y diapositivas según la nueva carta
Co-Authored-By: Claude Opus 5.5 <noreply@anthropic.com>
Claude-Session: https://claude.ai/code/session_01A2a3kkCw22mKtZ4h9yLDKX
</commit_message>
<xml_diff>
--- a/comite_etica_CGN/Exposicion_respuesta_Comite.pptx
+++ b/comite_etica_CGN/Exposicion_respuesta_Comite.pptx
@@ -918,7 +918,7 @@
           <a:lstStyle/>
           <a:p>
             <a:r>
-              <a:t>En síntesis: dos observaciones se sustentan sin modificar la pregunta y cinco se acogen con ajustes concretos y trazables.</a:t>
+              <a:t>En síntesis: seis observaciones dieron lugar a ajustes directos y trazables en el protocolo; en la primera se mantuvo la delimitación de la población y se amplió su fundamentación.</a:t>
             </a:r>
           </a:p>
         </p:txBody>
@@ -1058,7 +1058,7 @@
           <a:lstStyle/>
           <a:p>
             <a:r>
-              <a:t>La respuesta sigue tres criterios. Primero, conservamos la pregunta de investigación: no cambiamos título, objetivos ni población, pero los sustentamos. Segundo, incorporamos todas las salvaguardas pedidas. Tercero, cada respuesta remite a la página exacta. Las observaciones 1 y 2 se sustentan; de la 3 a la 7 se acogen e incorporan.</a:t>
+              <a:t>Analizamos individualmente las siete observaciones. La mayoría dieron lugar a modificaciones directas del protocolo. Respecto de la recomendación de redefinir la población exclusivamente por rechazo transfusional, se mantuvo la delimitación original y se amplió su fundamentación científica, metodológica, ética y normativa. En la observación 2 se incorporó la diferenciación entre identidad religiosa y decisión clínica, sin modificar título ni objetivos. Cada respuesta remite a la página exacta del protocolo.</a:t>
             </a:r>
           </a:p>
         </p:txBody>
@@ -1128,7 +1128,7 @@
           <a:lstStyle/>
           <a:p>
             <a:r>
-              <a:t>Valoramos la alternativa propuesta, pero concluimos que no responde la misma pregunta. Cuatro razones: la evidencia con la que comparamos define su población como Testigos de Jehová; durante 2020–2025 la negativa en este grupo era homogénea y documentada; el estudio de referencia de Pattakos usó exactamente este enfoque; y existe un deber de justicia, porque la Corte Constitucional reconoce esta prestación. Además, la religión es constante en la cohorte: no se analiza ni se compara.</a:t>
+              <a:t>La recomendación fue analizada en detalle. Una cohorte definida exclusivamente por rechazo transfusional respondería una pregunta distinta y reduciría la comparabilidad con la literatura que sustenta el vacío de conocimiento. Cuatro razones: la evidencia con la que comparamos define su población como Testigos de Jehová; durante 2020–2025 la negativa en este grupo era homogénea y documentada; el estudio de referencia de Pattakos usó exactamente este enfoque; y existe un deber de justicia, porque la Corte Constitucional reconoce esta prestación. Además, la afiliación religiosa no es variable de exposición ni de comparación: al ser constante en la cohorte, no puede estimarse su asociación con los desenlaces.</a:t>
             </a:r>
           </a:p>
         </p:txBody>
@@ -1268,7 +1268,7 @@
           <a:lstStyle/>
           <a:p>
             <a:r>
-              <a:t>Acogimos la diferenciación. El protocolo ahora define dos condiciones independientes: la identidad religiosa, que delimita la población, y la decisión clínica individual, que define la elegibilidad y el perfil de aceptación. La primera nunca se usa para inferir la segunda. El título y los objetivos no se modifican porque ya exigían el rechazo documentado; se precisaron los criterios 2 y 4, y la base analítica no almacena la afiliación religiosa.</a:t>
+              <a:t>La observación fue incorporada en cuanto a la diferenciación explícita entre identidad religiosa y decisión clínica. El protocolo ahora define dos condiciones independientes: la identidad religiosa, que delimita la población, y la decisión clínica individual, que define la elegibilidad y el perfil de aceptación. La primera nunca se usa para inferir la segunda. El título y los objetivos no se modifican porque ya exigían el rechazo documentado; se precisaron los criterios 2 y 4, y la base analítica no almacena la afiliación religiosa.</a:t>
             </a:r>
           </a:p>
         </p:txBody>
@@ -1408,7 +1408,7 @@
           <a:lstStyle/>
           <a:p>
             <a:r>
-              <a:t>Compartimos el principio de que lo retrospectivo no basta. Por eso verificamos uno por uno los supuestos del literal a del artículo 11: es documental, no identifica al participante y no trata aspectos sensitivos de la conducta, porque no indaga ni analiza creencias; la condición religiosa solo delimita la población. El único riesgo es informacional y se controla con el plan de datos. La clasificación final corresponde al Comité.</a:t>
+              <a:t>Se acoge la observación: el protocolo no presume que el carácter retrospectivo determine el riesgo ni la dispensa; ambos se sustentan de forma independiente y quedan sujetos a la valoración del Comité. Verificamos uno por uno los supuestos del literal a del artículo 11: es documental, no identifica al participante y no trata aspectos sensitivos de la conducta, porque no indaga ni analiza creencias; la condición religiosa solo delimita la población. El único riesgo es informacional y se controla con el plan de datos, porque la condición religiosa es además un dato sensible según la Ley 1581 de 2012.</a:t>
             </a:r>
           </a:p>
         </p:txBody>
@@ -20511,7 +20511,7 @@
                             <a:srgbClr val="333333"/>
                           </a:solidFill>
                         </a:rPr>
-                        <a:t>Se sustenta</a:t>
+                        <a:t>Se fundamenta</a:t>
                       </a:r>
                     </a:p>
                   </a:txBody>
@@ -20532,7 +20532,7 @@
                             <a:srgbClr val="333333"/>
                           </a:solidFill>
                         </a:rPr>
-                        <a:t>Fundamentación y precedentes con aval ético</a:t>
+                        <a:t>Se mantiene la delimitación; fundamentación y precedentes</a:t>
                       </a:r>
                     </a:p>
                   </a:txBody>
@@ -20618,7 +20618,7 @@
                             <a:srgbClr val="333333"/>
                           </a:solidFill>
                         </a:rPr>
-                        <a:t>Se sustenta y precisa</a:t>
+                        <a:t>Se acoge en parte</a:t>
                       </a:r>
                     </a:p>
                   </a:txBody>
@@ -20832,7 +20832,7 @@
                             <a:srgbClr val="333333"/>
                           </a:solidFill>
                         </a:rPr>
-                        <a:t>Se acoge y sustenta</a:t>
+                        <a:t>Se acoge</a:t>
                       </a:r>
                     </a:p>
                   </a:txBody>
@@ -22504,7 +22504,7 @@
                   <a:srgbClr val="80006B"/>
                 </a:solidFill>
               </a:rPr>
-              <a:t>Se conserva la pregunta</a:t>
+              <a:t>Se mantiene la delimitación</a:t>
             </a:r>
           </a:p>
         </p:txBody>
@@ -22542,7 +22542,7 @@
                   <a:srgbClr val="333333"/>
                 </a:solidFill>
               </a:rPr>
-              <a:t>Título, objetivos y población se mantienen y se sustentan con argumentos y precedentes.</a:t>
+              <a:t>Diseño, título, objetivos y población se mantienen; se amplían su fundamentación y las salvaguardas.</a:t>
             </a:r>
           </a:p>
         </p:txBody>
@@ -23084,7 +23084,7 @@
                   <a:srgbClr val="FFFFFF"/>
                 </a:solidFill>
               </a:rPr>
-              <a:t>Se sustenta</a:t>
+              <a:t>Se fundamenta</a:t>
             </a:r>
           </a:p>
         </p:txBody>
@@ -23098,158 +23098,6 @@
         <p:spPr>
           <a:xfrm>
             <a:off x="7315200" y="3264408"/>
-            <a:ext cx="603504" cy="603504"/>
-          </a:xfrm>
-          <a:prstGeom prst="ellipse">
-            <a:avLst/>
-          </a:prstGeom>
-          <a:solidFill>
-            <a:srgbClr val="80006B"/>
-          </a:solidFill>
-          <a:ln>
-            <a:noFill/>
-          </a:ln>
-          <a:effectLst/>
-        </p:spPr>
-        <p:style>
-          <a:lnRef idx="1">
-            <a:schemeClr val="accent1"/>
-          </a:lnRef>
-          <a:fillRef idx="3">
-            <a:schemeClr val="accent1"/>
-          </a:fillRef>
-          <a:effectRef idx="2">
-            <a:schemeClr val="accent1"/>
-          </a:effectRef>
-          <a:fontRef idx="minor">
-            <a:schemeClr val="lt1"/>
-          </a:fontRef>
-        </p:style>
-        <p:txBody>
-          <a:bodyPr rtlCol="0" anchor="ctr" wrap="square" lIns="0" rIns="0" tIns="0" bIns="0"/>
-          <a:lstStyle/>
-          <a:p>
-            <a:pPr algn="ctr">
-              <a:spcAft>
-                <a:spcPts val="600"/>
-              </a:spcAft>
-            </a:pPr>
-            <a:r>
-              <a:rPr sz="2200" b="1" i="0">
-                <a:solidFill>
-                  <a:srgbClr val="FFFFFF"/>
-                </a:solidFill>
-              </a:rPr>
-              <a:t>2</a:t>
-            </a:r>
-          </a:p>
-        </p:txBody>
-      </p:sp>
-      <p:sp>
-        <p:nvSpPr>
-          <p:cNvPr id="12384" name="TextBox 12383"/>
-          <p:cNvSpPr txBox="1"/>
-          <p:nvPr/>
-        </p:nvSpPr>
-        <p:spPr>
-          <a:xfrm>
-            <a:off x="8092440" y="3282696"/>
-            <a:ext cx="4480560" cy="566928"/>
-          </a:xfrm>
-          <a:prstGeom prst="rect">
-            <a:avLst/>
-          </a:prstGeom>
-          <a:noFill/>
-        </p:spPr>
-        <p:txBody>
-          <a:bodyPr wrap="square" anchor="ctr" lIns="73152" rIns="73152" tIns="73152" bIns="73152">
-            <a:spAutoFit/>
-          </a:bodyPr>
-          <a:lstStyle/>
-          <a:p>
-            <a:pPr algn="l">
-              <a:spcAft>
-                <a:spcPts val="600"/>
-              </a:spcAft>
-            </a:pPr>
-            <a:r>
-              <a:rPr sz="2200" b="0" i="0">
-                <a:solidFill>
-                  <a:srgbClr val="333333"/>
-                </a:solidFill>
-              </a:rPr>
-              <a:t>Coherencia del protocolo</a:t>
-            </a:r>
-          </a:p>
-        </p:txBody>
-      </p:sp>
-      <p:sp>
-        <p:nvSpPr>
-          <p:cNvPr id="12385" name="Rounded Rectangle 12384"/>
-          <p:cNvSpPr/>
-          <p:nvPr/>
-        </p:nvSpPr>
-        <p:spPr>
-          <a:xfrm>
-            <a:off x="12527280" y="3355848"/>
-            <a:ext cx="2286000" cy="420624"/>
-          </a:xfrm>
-          <a:prstGeom prst="roundRect">
-            <a:avLst>
-              <a:gd name="adj" fmla="val 50000"/>
-            </a:avLst>
-          </a:prstGeom>
-          <a:solidFill>
-            <a:srgbClr val="80006B"/>
-          </a:solidFill>
-          <a:ln>
-            <a:noFill/>
-          </a:ln>
-          <a:effectLst/>
-        </p:spPr>
-        <p:style>
-          <a:lnRef idx="1">
-            <a:schemeClr val="accent1"/>
-          </a:lnRef>
-          <a:fillRef idx="3">
-            <a:schemeClr val="accent1"/>
-          </a:fillRef>
-          <a:effectRef idx="2">
-            <a:schemeClr val="accent1"/>
-          </a:effectRef>
-          <a:fontRef idx="minor">
-            <a:schemeClr val="lt1"/>
-          </a:fontRef>
-        </p:style>
-        <p:txBody>
-          <a:bodyPr rtlCol="0" anchor="ctr" wrap="square" lIns="0" rIns="0" tIns="0" bIns="0"/>
-          <a:lstStyle/>
-          <a:p>
-            <a:pPr algn="ctr">
-              <a:spcAft>
-                <a:spcPts val="600"/>
-              </a:spcAft>
-            </a:pPr>
-            <a:r>
-              <a:rPr sz="1600" b="1" i="0">
-                <a:solidFill>
-                  <a:srgbClr val="FFFFFF"/>
-                </a:solidFill>
-              </a:rPr>
-              <a:t>Se sustenta y precisa</a:t>
-            </a:r>
-          </a:p>
-        </p:txBody>
-      </p:sp>
-      <p:sp>
-        <p:nvSpPr>
-          <p:cNvPr id="12386" name="Oval 12385"/>
-          <p:cNvSpPr/>
-          <p:nvPr/>
-        </p:nvSpPr>
-        <p:spPr>
-          <a:xfrm>
-            <a:off x="7315200" y="4105656"/>
             <a:ext cx="603504" cy="603504"/>
           </a:xfrm>
           <a:prstGeom prst="ellipse">
@@ -23292,20 +23140,20 @@
                   <a:srgbClr val="FFFFFF"/>
                 </a:solidFill>
               </a:rPr>
-              <a:t>3</a:t>
-            </a:r>
-          </a:p>
-        </p:txBody>
-      </p:sp>
-      <p:sp>
-        <p:nvSpPr>
-          <p:cNvPr id="12387" name="TextBox 12386"/>
+              <a:t>2</a:t>
+            </a:r>
+          </a:p>
+        </p:txBody>
+      </p:sp>
+      <p:sp>
+        <p:nvSpPr>
+          <p:cNvPr id="12384" name="TextBox 12383"/>
           <p:cNvSpPr txBox="1"/>
           <p:nvPr/>
         </p:nvSpPr>
         <p:spPr>
           <a:xfrm>
-            <a:off x="8092440" y="4123944"/>
+            <a:off x="8092440" y="3282696"/>
             <a:ext cx="4480560" cy="566928"/>
           </a:xfrm>
           <a:prstGeom prst="rect">
@@ -23330,20 +23178,20 @@
                   <a:srgbClr val="333333"/>
                 </a:solidFill>
               </a:rPr>
-              <a:t>Contexto religioso y temporal</a:t>
-            </a:r>
-          </a:p>
-        </p:txBody>
-      </p:sp>
-      <p:sp>
-        <p:nvSpPr>
-          <p:cNvPr id="12388" name="Rounded Rectangle 12387"/>
+              <a:t>Coherencia del protocolo</a:t>
+            </a:r>
+          </a:p>
+        </p:txBody>
+      </p:sp>
+      <p:sp>
+        <p:nvSpPr>
+          <p:cNvPr id="12385" name="Rounded Rectangle 12384"/>
           <p:cNvSpPr/>
           <p:nvPr/>
         </p:nvSpPr>
         <p:spPr>
           <a:xfrm>
-            <a:off x="12527280" y="4197096"/>
+            <a:off x="12527280" y="3355848"/>
             <a:ext cx="2286000" cy="420624"/>
           </a:xfrm>
           <a:prstGeom prst="roundRect">
@@ -23388,20 +23236,20 @@
                   <a:srgbClr val="FFFFFF"/>
                 </a:solidFill>
               </a:rPr>
-              <a:t>Se acoge</a:t>
-            </a:r>
-          </a:p>
-        </p:txBody>
-      </p:sp>
-      <p:sp>
-        <p:nvSpPr>
-          <p:cNvPr id="12389" name="Oval 12388"/>
+              <a:t>Se acoge en parte</a:t>
+            </a:r>
+          </a:p>
+        </p:txBody>
+      </p:sp>
+      <p:sp>
+        <p:nvSpPr>
+          <p:cNvPr id="12386" name="Oval 12385"/>
           <p:cNvSpPr/>
           <p:nvPr/>
         </p:nvSpPr>
         <p:spPr>
           <a:xfrm>
-            <a:off x="7315200" y="4946904"/>
+            <a:off x="7315200" y="4105656"/>
             <a:ext cx="603504" cy="603504"/>
           </a:xfrm>
           <a:prstGeom prst="ellipse">
@@ -23444,20 +23292,20 @@
                   <a:srgbClr val="FFFFFF"/>
                 </a:solidFill>
               </a:rPr>
-              <a:t>4</a:t>
-            </a:r>
-          </a:p>
-        </p:txBody>
-      </p:sp>
-      <p:sp>
-        <p:nvSpPr>
-          <p:cNvPr id="12390" name="TextBox 12389"/>
+              <a:t>3</a:t>
+            </a:r>
+          </a:p>
+        </p:txBody>
+      </p:sp>
+      <p:sp>
+        <p:nvSpPr>
+          <p:cNvPr id="12387" name="TextBox 12386"/>
           <p:cNvSpPr txBox="1"/>
           <p:nvPr/>
         </p:nvSpPr>
         <p:spPr>
           <a:xfrm>
-            <a:off x="8092440" y="4965192"/>
+            <a:off x="8092440" y="4123944"/>
             <a:ext cx="4480560" cy="566928"/>
           </a:xfrm>
           <a:prstGeom prst="rect">
@@ -23482,20 +23330,20 @@
                   <a:srgbClr val="333333"/>
                 </a:solidFill>
               </a:rPr>
-              <a:t>Riesgo y consentimiento</a:t>
-            </a:r>
-          </a:p>
-        </p:txBody>
-      </p:sp>
-      <p:sp>
-        <p:nvSpPr>
-          <p:cNvPr id="12391" name="Rounded Rectangle 12390"/>
+              <a:t>Contexto religioso y temporal</a:t>
+            </a:r>
+          </a:p>
+        </p:txBody>
+      </p:sp>
+      <p:sp>
+        <p:nvSpPr>
+          <p:cNvPr id="12388" name="Rounded Rectangle 12387"/>
           <p:cNvSpPr/>
           <p:nvPr/>
         </p:nvSpPr>
         <p:spPr>
           <a:xfrm>
-            <a:off x="12527280" y="5038344"/>
+            <a:off x="12527280" y="4197096"/>
             <a:ext cx="2286000" cy="420624"/>
           </a:xfrm>
           <a:prstGeom prst="roundRect">
@@ -23540,7 +23388,159 @@
                   <a:srgbClr val="FFFFFF"/>
                 </a:solidFill>
               </a:rPr>
-              <a:t>Se acoge y sustenta</a:t>
+              <a:t>Se acoge</a:t>
+            </a:r>
+          </a:p>
+        </p:txBody>
+      </p:sp>
+      <p:sp>
+        <p:nvSpPr>
+          <p:cNvPr id="12389" name="Oval 12388"/>
+          <p:cNvSpPr/>
+          <p:nvPr/>
+        </p:nvSpPr>
+        <p:spPr>
+          <a:xfrm>
+            <a:off x="7315200" y="4946904"/>
+            <a:ext cx="603504" cy="603504"/>
+          </a:xfrm>
+          <a:prstGeom prst="ellipse">
+            <a:avLst/>
+          </a:prstGeom>
+          <a:solidFill>
+            <a:srgbClr val="FF5F3F"/>
+          </a:solidFill>
+          <a:ln>
+            <a:noFill/>
+          </a:ln>
+          <a:effectLst/>
+        </p:spPr>
+        <p:style>
+          <a:lnRef idx="1">
+            <a:schemeClr val="accent1"/>
+          </a:lnRef>
+          <a:fillRef idx="3">
+            <a:schemeClr val="accent1"/>
+          </a:fillRef>
+          <a:effectRef idx="2">
+            <a:schemeClr val="accent1"/>
+          </a:effectRef>
+          <a:fontRef idx="minor">
+            <a:schemeClr val="lt1"/>
+          </a:fontRef>
+        </p:style>
+        <p:txBody>
+          <a:bodyPr rtlCol="0" anchor="ctr" wrap="square" lIns="0" rIns="0" tIns="0" bIns="0"/>
+          <a:lstStyle/>
+          <a:p>
+            <a:pPr algn="ctr">
+              <a:spcAft>
+                <a:spcPts val="600"/>
+              </a:spcAft>
+            </a:pPr>
+            <a:r>
+              <a:rPr sz="2200" b="1" i="0">
+                <a:solidFill>
+                  <a:srgbClr val="FFFFFF"/>
+                </a:solidFill>
+              </a:rPr>
+              <a:t>4</a:t>
+            </a:r>
+          </a:p>
+        </p:txBody>
+      </p:sp>
+      <p:sp>
+        <p:nvSpPr>
+          <p:cNvPr id="12390" name="TextBox 12389"/>
+          <p:cNvSpPr txBox="1"/>
+          <p:nvPr/>
+        </p:nvSpPr>
+        <p:spPr>
+          <a:xfrm>
+            <a:off x="8092440" y="4965192"/>
+            <a:ext cx="4480560" cy="566928"/>
+          </a:xfrm>
+          <a:prstGeom prst="rect">
+            <a:avLst/>
+          </a:prstGeom>
+          <a:noFill/>
+        </p:spPr>
+        <p:txBody>
+          <a:bodyPr wrap="square" anchor="ctr" lIns="73152" rIns="73152" tIns="73152" bIns="73152">
+            <a:spAutoFit/>
+          </a:bodyPr>
+          <a:lstStyle/>
+          <a:p>
+            <a:pPr algn="l">
+              <a:spcAft>
+                <a:spcPts val="600"/>
+              </a:spcAft>
+            </a:pPr>
+            <a:r>
+              <a:rPr sz="2200" b="0" i="0">
+                <a:solidFill>
+                  <a:srgbClr val="333333"/>
+                </a:solidFill>
+              </a:rPr>
+              <a:t>Riesgo y consentimiento</a:t>
+            </a:r>
+          </a:p>
+        </p:txBody>
+      </p:sp>
+      <p:sp>
+        <p:nvSpPr>
+          <p:cNvPr id="12391" name="Rounded Rectangle 12390"/>
+          <p:cNvSpPr/>
+          <p:nvPr/>
+        </p:nvSpPr>
+        <p:spPr>
+          <a:xfrm>
+            <a:off x="12527280" y="5038344"/>
+            <a:ext cx="2286000" cy="420624"/>
+          </a:xfrm>
+          <a:prstGeom prst="roundRect">
+            <a:avLst>
+              <a:gd name="adj" fmla="val 50000"/>
+            </a:avLst>
+          </a:prstGeom>
+          <a:solidFill>
+            <a:srgbClr val="FF5F3F"/>
+          </a:solidFill>
+          <a:ln>
+            <a:noFill/>
+          </a:ln>
+          <a:effectLst/>
+        </p:spPr>
+        <p:style>
+          <a:lnRef idx="1">
+            <a:schemeClr val="accent1"/>
+          </a:lnRef>
+          <a:fillRef idx="3">
+            <a:schemeClr val="accent1"/>
+          </a:fillRef>
+          <a:effectRef idx="2">
+            <a:schemeClr val="accent1"/>
+          </a:effectRef>
+          <a:fontRef idx="minor">
+            <a:schemeClr val="lt1"/>
+          </a:fontRef>
+        </p:style>
+        <p:txBody>
+          <a:bodyPr rtlCol="0" anchor="ctr" wrap="square" lIns="0" rIns="0" tIns="0" bIns="0"/>
+          <a:lstStyle/>
+          <a:p>
+            <a:pPr algn="ctr">
+              <a:spcAft>
+                <a:spcPts val="600"/>
+              </a:spcAft>
+            </a:pPr>
+            <a:r>
+              <a:rPr sz="1600" b="1" i="0">
+                <a:solidFill>
+                  <a:srgbClr val="FFFFFF"/>
+                </a:solidFill>
+              </a:rPr>
+              <a:t>Se acoge</a:t>
             </a:r>
           </a:p>
         </p:txBody>
@@ -24294,7 +24294,7 @@
                   <a:srgbClr val="333333"/>
                 </a:solidFill>
               </a:rPr>
-              <a:t>se mantiene la población: una cohorte definida solo por el rechazo respondería otra pregunta.</a:t>
+              <a:t>se mantiene la delimitación; definirla solo por rechazo cambiaría la pregunta y reduciría la comparabilidad.</a:t>
             </a:r>
           </a:p>
         </p:txBody>
@@ -24307,8 +24307,8 @@
         </p:nvSpPr>
         <p:spPr>
           <a:xfrm>
-            <a:off x="914400" y="3611880"/>
-            <a:ext cx="3337560" cy="4343400"/>
+            <a:off x="914400" y="3886200"/>
+            <a:ext cx="3337560" cy="4069080"/>
           </a:xfrm>
           <a:prstGeom prst="roundRect">
             <a:avLst>
@@ -24353,7 +24353,7 @@
         </p:nvSpPr>
         <p:spPr>
           <a:xfrm>
-            <a:off x="1097280" y="3794760"/>
+            <a:off x="1097280" y="4069080"/>
             <a:ext cx="566928" cy="566928"/>
           </a:xfrm>
           <a:prstGeom prst="ellipse">
@@ -24409,7 +24409,7 @@
         </p:nvSpPr>
         <p:spPr>
           <a:xfrm>
-            <a:off x="1828800" y="3721608"/>
+            <a:off x="1828800" y="3995928"/>
             <a:ext cx="2331720" cy="777240"/>
           </a:xfrm>
           <a:prstGeom prst="rect">
@@ -24447,8 +24447,8 @@
         </p:nvSpPr>
         <p:spPr>
           <a:xfrm>
-            <a:off x="1097280" y="4617720"/>
-            <a:ext cx="2971800" cy="3246120"/>
+            <a:off x="1097280" y="4892040"/>
+            <a:ext cx="2971800" cy="2971800"/>
           </a:xfrm>
           <a:prstGeom prst="rect">
             <a:avLst/>
@@ -24485,8 +24485,8 @@
         </p:nvSpPr>
         <p:spPr>
           <a:xfrm>
-            <a:off x="4434840" y="3611880"/>
-            <a:ext cx="3337560" cy="4343400"/>
+            <a:off x="4434840" y="3886200"/>
+            <a:ext cx="3337560" cy="4069080"/>
           </a:xfrm>
           <a:prstGeom prst="roundRect">
             <a:avLst>
@@ -24531,7 +24531,7 @@
         </p:nvSpPr>
         <p:spPr>
           <a:xfrm>
-            <a:off x="4617720" y="3794760"/>
+            <a:off x="4617720" y="4069080"/>
             <a:ext cx="566928" cy="566928"/>
           </a:xfrm>
           <a:prstGeom prst="ellipse">
@@ -24587,7 +24587,7 @@
         </p:nvSpPr>
         <p:spPr>
           <a:xfrm>
-            <a:off x="5349240" y="3721608"/>
+            <a:off x="5349240" y="3995928"/>
             <a:ext cx="2331720" cy="777240"/>
           </a:xfrm>
           <a:prstGeom prst="rect">
@@ -24625,8 +24625,8 @@
         </p:nvSpPr>
         <p:spPr>
           <a:xfrm>
-            <a:off x="4617720" y="4617720"/>
-            <a:ext cx="2971800" cy="3246120"/>
+            <a:off x="4617720" y="4892040"/>
+            <a:ext cx="2971800" cy="2971800"/>
           </a:xfrm>
           <a:prstGeom prst="rect">
             <a:avLst/>
@@ -24663,8 +24663,8 @@
         </p:nvSpPr>
         <p:spPr>
           <a:xfrm>
-            <a:off x="7955279" y="3611880"/>
-            <a:ext cx="3337560" cy="4343400"/>
+            <a:off x="7955279" y="3886200"/>
+            <a:ext cx="3337560" cy="4069080"/>
           </a:xfrm>
           <a:prstGeom prst="roundRect">
             <a:avLst>
@@ -24709,7 +24709,7 @@
         </p:nvSpPr>
         <p:spPr>
           <a:xfrm>
-            <a:off x="8138159" y="3794760"/>
+            <a:off x="8138159" y="4069080"/>
             <a:ext cx="566928" cy="566928"/>
           </a:xfrm>
           <a:prstGeom prst="ellipse">
@@ -24765,7 +24765,7 @@
         </p:nvSpPr>
         <p:spPr>
           <a:xfrm>
-            <a:off x="8869680" y="3721608"/>
+            <a:off x="8869680" y="3995928"/>
             <a:ext cx="2331720" cy="777240"/>
           </a:xfrm>
           <a:prstGeom prst="rect">
@@ -24803,8 +24803,8 @@
         </p:nvSpPr>
         <p:spPr>
           <a:xfrm>
-            <a:off x="8138159" y="4617720"/>
-            <a:ext cx="2971800" cy="3246120"/>
+            <a:off x="8138159" y="4892040"/>
+            <a:ext cx="2971800" cy="2971800"/>
           </a:xfrm>
           <a:prstGeom prst="rect">
             <a:avLst/>
@@ -24841,8 +24841,8 @@
         </p:nvSpPr>
         <p:spPr>
           <a:xfrm>
-            <a:off x="11475720" y="3611880"/>
-            <a:ext cx="3337560" cy="4343400"/>
+            <a:off x="11475720" y="3886200"/>
+            <a:ext cx="3337560" cy="4069080"/>
           </a:xfrm>
           <a:prstGeom prst="roundRect">
             <a:avLst>
@@ -24887,7 +24887,7 @@
         </p:nvSpPr>
         <p:spPr>
           <a:xfrm>
-            <a:off x="11658600" y="3794760"/>
+            <a:off x="11658600" y="4069080"/>
             <a:ext cx="566928" cy="566928"/>
           </a:xfrm>
           <a:prstGeom prst="ellipse">
@@ -24943,7 +24943,7 @@
         </p:nvSpPr>
         <p:spPr>
           <a:xfrm>
-            <a:off x="12390120" y="3721608"/>
+            <a:off x="12390120" y="3995928"/>
             <a:ext cx="2331720" cy="777240"/>
           </a:xfrm>
           <a:prstGeom prst="rect">
@@ -24981,8 +24981,8 @@
         </p:nvSpPr>
         <p:spPr>
           <a:xfrm>
-            <a:off x="11658600" y="4617720"/>
-            <a:ext cx="2971800" cy="3246120"/>
+            <a:off x="11658600" y="4892040"/>
+            <a:ext cx="2971800" cy="2971800"/>
           </a:xfrm>
           <a:prstGeom prst="rect">
             <a:avLst/>

</xml_diff>

<commit_message>
Comité CGN: quitar texto del pie de página en las diapositivas
Co-Authored-By: Claude Opus 5.5 <noreply@anthropic.com>
Claude-Session: https://claude.ai/code/session_01A2a3kkCw22mKtZ4h9yLDKX
</commit_message>
<xml_diff>
--- a/comite_etica_CGN/Exposicion_respuesta_Comite.pptx
+++ b/comite_etica_CGN/Exposicion_respuesta_Comite.pptx
@@ -1915,42 +1915,6 @@
           </a:prstGeom>
         </p:spPr>
       </p:pic>
-      <p:sp>
-        <p:nvSpPr>
-          <p:cNvPr id="6" name="Text 1"/>
-          <p:cNvSpPr/>
-          <p:nvPr/>
-        </p:nvSpPr>
-        <p:spPr>
-          <a:xfrm>
-            <a:off x="2286000" y="6355080"/>
-            <a:ext cx="7315200" cy="320040"/>
-          </a:xfrm>
-          <a:prstGeom prst="rect">
-            <a:avLst/>
-          </a:prstGeom>
-          <a:noFill/>
-          <a:ln/>
-        </p:spPr>
-        <p:txBody>
-          <a:bodyPr wrap="square" lIns="0" tIns="0" rIns="0" bIns="0" rtlCol="0" anchor="ctr"/>
-          <a:lstStyle/>
-          <a:p>
-            <a:pPr algn="l" indent="0" marL="0">
-              <a:buNone/>
-            </a:pPr>
-            <a:r>
-              <a:rPr lang="en-US" sz="1000" dirty="0">
-                <a:solidFill>
-                  <a:srgbClr val="6B6B6B"/>
-                </a:solidFill>
-              </a:rPr>
-              <a:t>Respuesta al Comité de Bioética en Investigación · Clínica General del Norte</a:t>
-            </a:r>
-            <a:endParaRPr lang="en-US" sz="1000" dirty="0"/>
-          </a:p>
-        </p:txBody>
-      </p:sp>
       <p:sp>
         <p:nvSpPr>
           <p:cNvPr id="25" name="Slide Number Placeholder 0"/>

</xml_diff>